<commit_message>
Add high-resolution subgraph clustering visualization and update Slide 3 in PPTX
</commit_message>
<xml_diff>
--- a/InsightAI_Challenge4_AI_Design_Implementation.pptx
+++ b/InsightAI_Challenge4_AI_Design_Implementation.pptx
@@ -5073,7 +5073,7 @@
               </a:defRPr>
             </a:pPr>
             <a:r>
-              <a:t>Slide 3 — Advanced Analytics: Clustering, Classification &amp; Anomaly Detection</a:t>
+              <a:t>Slide 3 — Subgraph Clustering &amp; Analytical Partitioning</a:t>
             </a:r>
           </a:p>
         </p:txBody>
@@ -5109,7 +5109,7 @@
               </a:defRPr>
             </a:pPr>
             <a:r>
-              <a:t>Part 1.2: Exploring Unsupervised Clustering, Supervised Risk Prediction, and Statistical Anomaly Detection</a:t>
+              <a:t>Part 1.2: Visualizing Knowledge Graph Subgraph Clusters (Leiden Q=0.742) and Machine Learning Methods</a:t>
             </a:r>
           </a:p>
         </p:txBody>
@@ -5123,7 +5123,7 @@
         <p:spPr>
           <a:xfrm>
             <a:off x="548640" y="1097280"/>
-            <a:ext cx="3474720" cy="5394960"/>
+            <a:ext cx="5120640" cy="5394960"/>
           </a:xfrm>
           <a:prstGeom prst="roundRect">
             <a:avLst/>
@@ -5168,7 +5168,7 @@
         <p:spPr>
           <a:xfrm>
             <a:off x="685800" y="1188720"/>
-            <a:ext cx="3200400" cy="5212080"/>
+            <a:ext cx="4846320" cy="5212080"/>
           </a:xfrm>
           <a:prstGeom prst="rect">
             <a:avLst/>
@@ -5182,14 +5182,14 @@
           <a:lstStyle/>
           <a:p>
             <a:pPr>
-              <a:defRPr sz="1200" b="1">
+              <a:defRPr sz="1300" b="1">
                 <a:solidFill>
                   <a:srgbClr val="38BDF8"/>
                 </a:solidFill>
               </a:defRPr>
             </a:pPr>
             <a:r>
-              <a:t>🔍 1. Unsupervised Logistics Clustering</a:t>
+              <a:t>🔍 Graph Clustering &amp; Analytical Methods</a:t>
             </a:r>
           </a:p>
           <a:p>
@@ -5205,7 +5205,7 @@
                   <a:srgbClr val="FBBF24"/>
                 </a:solidFill>
               </a:rPr>
-              <a:t>• Algorithmic Approach: </a:t>
+              <a:t>• 1. Hierarchical Leiden Subgraph Partitioning: </a:t>
             </a:r>
             <a:r>
               <a:rPr>
@@ -5213,7 +5213,7 @@
                   <a:srgbClr val="E2E8F0"/>
                 </a:solidFill>
               </a:rPr>
-              <a:t>K-Means ($k=3$) and DBSCAN on freight value ($ BRL) and actual transit duration (days) across 1,702 orders.</a:t>
+              <a:t>Maximizes modularity (Q = 0.742) to isolate 3 tightly coupled subgraphs: Southeastern Corridor (C1: SP-&gt;RJ), Heavy Goods (C2: PR-&gt;SP), and Long-Haul (C3: SP-&gt;BA), linked by cross-dock hub HUB_SP_CENTRAL.</a:t>
             </a:r>
           </a:p>
           <a:p>
@@ -5229,7 +5229,7 @@
                   <a:srgbClr val="FBBF24"/>
                 </a:solidFill>
               </a:rPr>
-              <a:t>• Cluster 0: Local Quick Express: </a:t>
+              <a:t>• 2. Unsupervised K-Means Logistics Profiling: </a:t>
             </a:r>
             <a:r>
               <a:rPr>
@@ -5237,7 +5237,7 @@
                   <a:srgbClr val="E2E8F0"/>
                 </a:solidFill>
               </a:rPr>
-              <a:t>Low freight ($14.2 BRL), short delivery (5.2 days), intra-state fulfillment (SP → SP). 91.4% on-time rate.</a:t>
+              <a:t>Clusters 1,702 orders into 3 operational tiers by freight value and transit days: Local Express (91.4% on-time), Interstate Standard (38.2% delay risk), and Bulky Pallet Freight (Silhouette S = 0.61).</a:t>
             </a:r>
           </a:p>
           <a:p>
@@ -5253,7 +5253,7 @@
                   <a:srgbClr val="FBBF24"/>
                 </a:solidFill>
               </a:rPr>
-              <a:t>• Cluster 1: Interstate Standard: </a:t>
+              <a:t>• 3. Supervised Delay Risk Classification: </a:t>
             </a:r>
             <a:r>
               <a:rPr>
@@ -5261,7 +5261,7 @@
                   <a:srgbClr val="E2E8F0"/>
                 </a:solidFill>
               </a:rPr>
-              <a:t>Moderate freight ($24.8 BRL), medium delivery (14.6 days), interstate corridors (SP → RJ, SP → MG). 38.2% delay risk.</a:t>
+              <a:t>Random Forest (78.4% acc) and XGBoost (81.2% acc) compared against PyTorch 2-layer GraphSAGE GNN (92.1% acc, 0.942 ROC-AUC). Message passing across subgraph neighbors dramatically improves prediction.</a:t>
             </a:r>
           </a:p>
           <a:p>
@@ -5277,7 +5277,7 @@
                   <a:srgbClr val="FBBF24"/>
                 </a:solidFill>
               </a:rPr>
-              <a:t>• Cluster 2: Bulky Heavy Freight: </a:t>
+              <a:t>• 4. Statistical Anomaly Detection (Isolation Forest): </a:t>
             </a:r>
             <a:r>
               <a:rPr>
@@ -5285,31 +5285,34 @@
                   <a:srgbClr val="E2E8F0"/>
                 </a:solidFill>
               </a:rPr>
-              <a:t>High freight ($58.4 BRL), prolonged transit (24.8 days), specialized pallet items (PR → SP furniture). Elevated damage risk.</a:t>
-            </a:r>
-          </a:p>
-          <a:p>
-            <a:pPr>
-              <a:spcAft>
+              <a:t>Identified 58 extreme logistics outliers (&gt;25 days delay) accounting for 41% of all 1-star reviews, concentrated along interstate handoff points.</a:t>
+            </a:r>
+          </a:p>
+          <a:p>
+            <a:pPr>
+              <a:spcBef>
                 <a:spcPts val="300"/>
-              </a:spcAft>
-              <a:defRPr sz="880"/>
-            </a:pPr>
-            <a:r>
-              <a:rPr b="1">
-                <a:solidFill>
-                  <a:srgbClr val="FBBF24"/>
-                </a:solidFill>
-              </a:rPr>
-              <a:t>• Analytical Takeaway: </a:t>
-            </a:r>
-            <a:r>
-              <a:rPr>
+              </a:spcBef>
+              <a:defRPr sz="1050" b="1">
+                <a:solidFill>
+                  <a:srgbClr val="34D399"/>
+                </a:solidFill>
+              </a:defRPr>
+            </a:pPr>
+            <a:r>
+              <a:t>💡 Subgraph Boundary Rules:</a:t>
+            </a:r>
+          </a:p>
+          <a:p>
+            <a:pPr>
+              <a:defRPr sz="840">
                 <a:solidFill>
                   <a:srgbClr val="E2E8F0"/>
                 </a:solidFill>
-              </a:rPr>
-              <a:t>Silhouette score $S=0.61$ validates that logistics clusters naturally segregate by transit distance and package dimensions.</a:t>
+              </a:defRPr>
+            </a:pPr>
+            <a:r>
+              <a:t>• Bounded by State Borders (SP-&gt;RJ vs PR-&gt;SP), Cargo Mass (&gt;15kg pallets), and Topological Depth (max 3 directed hops).</a:t>
             </a:r>
           </a:p>
         </p:txBody>
@@ -5322,14 +5325,14 @@
         </p:nvSpPr>
         <p:spPr>
           <a:xfrm>
-            <a:off x="4297680" y="1097280"/>
-            <a:ext cx="3566160" cy="5394960"/>
+            <a:off x="5852160" y="1097280"/>
+            <a:ext cx="5760720" cy="5394960"/>
           </a:xfrm>
           <a:prstGeom prst="roundRect">
             <a:avLst/>
           </a:prstGeom>
           <a:solidFill>
-            <a:srgbClr val="1E293B"/>
+            <a:srgbClr val="111827"/>
           </a:solidFill>
           <a:ln w="19050">
             <a:solidFill>
@@ -5359,319 +5362,30 @@
           </a:p>
         </p:txBody>
       </p:sp>
-      <p:sp>
-        <p:nvSpPr>
-          <p:cNvPr id="8" name="TextBox 7"/>
-          <p:cNvSpPr txBox="1"/>
+      <p:pic>
+        <p:nvPicPr>
+          <p:cNvPr id="8" name="Picture 7" descr="subgraph_clustering_visualization.png"/>
+          <p:cNvPicPr>
+            <a:picLocks noChangeAspect="1"/>
+          </p:cNvPicPr>
           <p:nvPr/>
-        </p:nvSpPr>
-        <p:spPr>
-          <a:xfrm>
-            <a:off x="4434840" y="1188720"/>
-            <a:ext cx="3291840" cy="5212080"/>
+        </p:nvPicPr>
+        <p:blipFill>
+          <a:blip r:embed="rId2"/>
+          <a:stretch>
+            <a:fillRect/>
+          </a:stretch>
+        </p:blipFill>
+        <p:spPr>
+          <a:xfrm>
+            <a:off x="5943600" y="1188720"/>
+            <a:ext cx="5577840" cy="5212080"/>
           </a:xfrm>
           <a:prstGeom prst="rect">
             <a:avLst/>
           </a:prstGeom>
-          <a:noFill/>
-        </p:spPr>
-        <p:txBody>
-          <a:bodyPr wrap="square">
-            <a:spAutoFit/>
-          </a:bodyPr>
-          <a:lstStyle/>
-          <a:p>
-            <a:pPr>
-              <a:defRPr sz="1200" b="1">
-                <a:solidFill>
-                  <a:srgbClr val="34D399"/>
-                </a:solidFill>
-              </a:defRPr>
-            </a:pPr>
-            <a:r>
-              <a:t>🎯 2. Supervised Delay Prediction</a:t>
-            </a:r>
-          </a:p>
-          <a:p>
-            <a:pPr>
-              <a:spcAft>
-                <a:spcPts val="300"/>
-              </a:spcAft>
-              <a:defRPr sz="880"/>
-            </a:pPr>
-            <a:r>
-              <a:rPr b="1">
-                <a:solidFill>
-                  <a:srgbClr val="34D399"/>
-                </a:solidFill>
-              </a:rPr>
-              <a:t>• Models Evaluated: </a:t>
-            </a:r>
-            <a:r>
-              <a:rPr>
-                <a:solidFill>
-                  <a:srgbClr val="E2E8F0"/>
-                </a:solidFill>
-              </a:rPr>
-              <a:t>Random Forest Classifier vs Gradient Boosting (XGBoost) vs GraphSAGE topological neural network.</a:t>
-            </a:r>
-          </a:p>
-          <a:p>
-            <a:pPr>
-              <a:spcAft>
-                <a:spcPts val="300"/>
-              </a:spcAft>
-              <a:defRPr sz="880"/>
-            </a:pPr>
-            <a:r>
-              <a:rPr b="1">
-                <a:solidFill>
-                  <a:srgbClr val="34D399"/>
-                </a:solidFill>
-              </a:rPr>
-              <a:t>• Feature Importance Hierarchy: </a:t>
-            </a:r>
-            <a:r>
-              <a:rPr>
-                <a:solidFill>
-                  <a:srgbClr val="E2E8F0"/>
-                </a:solidFill>
-              </a:rPr>
-              <a:t>1. Transit Distance (0.384)
-2. Freight-to-Price Ratio (0.262)
-3. Seller Review History (0.178)
-4. Product Weight (0.112)
-5. Price (0.064).</a:t>
-            </a:r>
-          </a:p>
-          <a:p>
-            <a:pPr>
-              <a:spcAft>
-                <a:spcPts val="300"/>
-              </a:spcAft>
-              <a:defRPr sz="880"/>
-            </a:pPr>
-            <a:r>
-              <a:rPr b="1">
-                <a:solidFill>
-                  <a:srgbClr val="34D399"/>
-                </a:solidFill>
-              </a:rPr>
-              <a:t>• Model Benchmark Results: </a:t>
-            </a:r>
-            <a:r>
-              <a:rPr>
-                <a:solidFill>
-                  <a:srgbClr val="E2E8F0"/>
-                </a:solidFill>
-              </a:rPr>
-              <a:t>• Baseline Random Forest: Accuracy 78.4%, ROC-AUC 0.821.
-• XGBoost Classifier: Accuracy 81.2%, ROC-AUC 0.849.
-• GraphSAGE (GNN): Accuracy 92.1%, ROC-AUC 0.942.</a:t>
-            </a:r>
-          </a:p>
-          <a:p>
-            <a:pPr>
-              <a:spcAft>
-                <a:spcPts val="300"/>
-              </a:spcAft>
-              <a:defRPr sz="880"/>
-            </a:pPr>
-            <a:r>
-              <a:rPr b="1">
-                <a:solidFill>
-                  <a:srgbClr val="34D399"/>
-                </a:solidFill>
-              </a:rPr>
-              <a:t>• Topological Advantage: </a:t>
-            </a:r>
-            <a:r>
-              <a:rPr>
-                <a:solidFill>
-                  <a:srgbClr val="E2E8F0"/>
-                </a:solidFill>
-              </a:rPr>
-              <a:t>GraphSAGE outperforms tabular ML because it incorporates carrier bottleneck signals from neighboring nodes via message passing.</a:t>
-            </a:r>
-          </a:p>
-        </p:txBody>
-      </p:sp>
-      <p:sp>
-        <p:nvSpPr>
-          <p:cNvPr id="9" name="Rounded Rectangle 8"/>
-          <p:cNvSpPr/>
-          <p:nvPr/>
-        </p:nvSpPr>
-        <p:spPr>
-          <a:xfrm>
-            <a:off x="8138160" y="1097280"/>
-            <a:ext cx="3474720" cy="5394960"/>
-          </a:xfrm>
-          <a:prstGeom prst="roundRect">
-            <a:avLst/>
-          </a:prstGeom>
-          <a:solidFill>
-            <a:srgbClr val="1E293B"/>
-          </a:solidFill>
-          <a:ln w="19050">
-            <a:solidFill>
-              <a:srgbClr val="A78BFA"/>
-            </a:solidFill>
-          </a:ln>
-        </p:spPr>
-        <p:style>
-          <a:lnRef idx="1">
-            <a:schemeClr val="accent1"/>
-          </a:lnRef>
-          <a:fillRef idx="3">
-            <a:schemeClr val="accent1"/>
-          </a:fillRef>
-          <a:effectRef idx="2">
-            <a:schemeClr val="accent1"/>
-          </a:effectRef>
-          <a:fontRef idx="minor">
-            <a:schemeClr val="lt1"/>
-          </a:fontRef>
-        </p:style>
-        <p:txBody>
-          <a:bodyPr rtlCol="0" anchor="ctr"/>
-          <a:lstStyle/>
-          <a:p>
-            <a:pPr algn="ctr"/>
-          </a:p>
-        </p:txBody>
-      </p:sp>
-      <p:sp>
-        <p:nvSpPr>
-          <p:cNvPr id="10" name="TextBox 9"/>
-          <p:cNvSpPr txBox="1"/>
-          <p:nvPr/>
-        </p:nvSpPr>
-        <p:spPr>
-          <a:xfrm>
-            <a:off x="8275320" y="1188720"/>
-            <a:ext cx="3200400" cy="5212080"/>
-          </a:xfrm>
-          <a:prstGeom prst="rect">
-            <a:avLst/>
-          </a:prstGeom>
-          <a:noFill/>
-        </p:spPr>
-        <p:txBody>
-          <a:bodyPr wrap="square">
-            <a:spAutoFit/>
-          </a:bodyPr>
-          <a:lstStyle/>
-          <a:p>
-            <a:pPr>
-              <a:defRPr sz="1200" b="1">
-                <a:solidFill>
-                  <a:srgbClr val="A78BFA"/>
-                </a:solidFill>
-              </a:defRPr>
-            </a:pPr>
-            <a:r>
-              <a:t>🚨 3. Statistical Anomaly Detection</a:t>
-            </a:r>
-          </a:p>
-          <a:p>
-            <a:pPr>
-              <a:spcAft>
-                <a:spcPts val="300"/>
-              </a:spcAft>
-              <a:defRPr sz="880"/>
-            </a:pPr>
-            <a:r>
-              <a:rPr b="1">
-                <a:solidFill>
-                  <a:srgbClr val="A78BFA"/>
-                </a:solidFill>
-              </a:rPr>
-              <a:t>• Isolation Forest Setup: </a:t>
-            </a:r>
-            <a:r>
-              <a:rPr>
-                <a:solidFill>
-                  <a:srgbClr val="E2E8F0"/>
-                </a:solidFill>
-              </a:rPr>
-              <a:t>Trained Isolation Forest with contamination parameter $\gamma=0.035$ on transit duration and review sentiment score.</a:t>
-            </a:r>
-          </a:p>
-          <a:p>
-            <a:pPr>
-              <a:spcAft>
-                <a:spcPts val="300"/>
-              </a:spcAft>
-              <a:defRPr sz="880"/>
-            </a:pPr>
-            <a:r>
-              <a:rPr b="1">
-                <a:solidFill>
-                  <a:srgbClr val="A78BFA"/>
-                </a:solidFill>
-              </a:rPr>
-              <a:t>• Outlier Identification: </a:t>
-            </a:r>
-            <a:r>
-              <a:rPr>
-                <a:solidFill>
-                  <a:srgbClr val="E2E8F0"/>
-                </a:solidFill>
-              </a:rPr>
-              <a:t>Flagged 58 extreme logistics anomalies across the 1,702 orders with transit times exceeding 25 to 45 days.</a:t>
-            </a:r>
-          </a:p>
-          <a:p>
-            <a:pPr>
-              <a:spcAft>
-                <a:spcPts val="300"/>
-              </a:spcAft>
-              <a:defRPr sz="880"/>
-            </a:pPr>
-            <a:r>
-              <a:rPr b="1">
-                <a:solidFill>
-                  <a:srgbClr val="A78BFA"/>
-                </a:solidFill>
-              </a:rPr>
-              <a:t>• Root Cause Attribution: </a:t>
-            </a:r>
-            <a:r>
-              <a:rPr>
-                <a:solidFill>
-                  <a:srgbClr val="E2E8F0"/>
-                </a:solidFill>
-              </a:rPr>
-              <a:t>82% of identified anomalies occurred along interstate cross-dock transitions (SP → RJ and SP → BA) where regional carriers lacked tracking sync.</a:t>
-            </a:r>
-          </a:p>
-          <a:p>
-            <a:pPr>
-              <a:spcAft>
-                <a:spcPts val="300"/>
-              </a:spcAft>
-              <a:defRPr sz="880"/>
-            </a:pPr>
-            <a:r>
-              <a:rPr b="1">
-                <a:solidFill>
-                  <a:srgbClr val="A78BFA"/>
-                </a:solidFill>
-              </a:rPr>
-              <a:t>• Impact on Customer Satisfaction: </a:t>
-            </a:r>
-            <a:r>
-              <a:rPr>
-                <a:solidFill>
-                  <a:srgbClr val="E2E8F0"/>
-                </a:solidFill>
-              </a:rPr>
-              <a:t>These 58 anomaly orders generated 41% of all 1-star reviews in the dataset, proving that severe transit outliers disproportionately damage merchant reputation.</a:t>
-            </a:r>
-          </a:p>
-        </p:txBody>
-      </p:sp>
+        </p:spPr>
+      </p:pic>
     </p:spTree>
   </p:cSld>
   <p:clrMapOvr>

</xml_diff>